<commit_message>
presentation and eda updates
</commit_message>
<xml_diff>
--- a/project_documents/DS785_Presentation3.pptx
+++ b/project_documents/DS785_Presentation3.pptx
@@ -6235,7 +6235,7 @@
           <a:p>
             <a:fld id="{87F82D20-900E-6C40-A05F-D83DFCD9E8C9}" type="datetimeFigureOut">
               <a:rPr lang="en-US" smtClean="0"/>
-              <a:t>7/5/26</a:t>
+              <a:t>7/9/26</a:t>
             </a:fld>
             <a:endParaRPr lang="en-US"/>
           </a:p>
@@ -6669,26 +6669,9 @@
           <a:bodyPr/>
           <a:lstStyle/>
           <a:p>
-            <a:pPr marL="0" marR="0" lvl="0" indent="0" algn="l" defTabSz="914400" rtl="0" eaLnBrk="1" fontAlgn="auto" latinLnBrk="0" hangingPunct="1">
-              <a:lnSpc>
-                <a:spcPct val="100000"/>
-              </a:lnSpc>
-              <a:spcBef>
-                <a:spcPts val="0"/>
-              </a:spcBef>
-              <a:spcAft>
-                <a:spcPts val="0"/>
-              </a:spcAft>
-              <a:buClrTx/>
-              <a:buSzTx/>
-              <a:buFontTx/>
-              <a:buNone/>
-              <a:tabLst/>
-              <a:defRPr/>
-            </a:pPr>
             <a:r>
-              <a:rPr lang="en-US" dirty="0"/>
-              <a:t>Before beginning statistical analysis, I first examined the overall structure of the dataset. The cleaned dataset contains 296 professional mountain bike product reviews representing 127 brands and six review types published between 2017 and 2026. During exploratory analysis, I engineered several additional variables, resulting in a total of 25 variables available for analysis. One characteristic that immediately stands out is the average review length of more than 2,200 words. These are detailed editorial reviews rather than short customer comments, which supports the use of transformer-based NLP models in the next phase of the project.</a:t>
+              <a:rPr lang="en-US" b="0" dirty="0"/>
+              <a:t>Before beginning statistical analysis, I first examined the overall structure of the dataset. The cleaned dataset contains 297 professional mountain bike product reviews, 17 original features, and metadata representing 151 manufacturers across six review types published between 2017 and 2026. During exploratory analysis, I engineered several additional features, such as article word count, average word length, publication year, and publication month, to support statistical analysis and downstream NLP modeling. One characteristic that immediately stands out is the average review length of more than 2,200 words, indicating these are detailed editorial reviews rather than short customer comments.</a:t>
             </a:r>
           </a:p>
         </p:txBody>
@@ -6793,11 +6776,8 @@
           <a:p>
             <a:r>
               <a:rPr lang="en-US" dirty="0"/>
-              <a:t>I also evaluated data completeness. Every record contains the full review text, which is the primary input for the NLP models. The largest source of missing values is the product name field. Based on the exploratory analysis, this appears to be a limitation of product extraction rather than a data collection issue and has been identified as a future ETL enhancement.</a:t>
+              <a:t>I also evaluated data completeness. Every record contains the full review text, which is the primary input for the NLP models. The largest source of missing values is the product name field. Remaining missing product names are largely associated with multi-product reviews or editorial articles rather than missing source data, so they are not expected to affect the downstream NLP modeling.</a:t>
             </a:r>
-          </a:p>
-          <a:p>
-            <a:endParaRPr lang="en-US" dirty="0"/>
           </a:p>
         </p:txBody>
       </p:sp>
@@ -6901,7 +6881,7 @@
           <a:p>
             <a:r>
               <a:rPr lang="en-US" dirty="0"/>
-              <a:t>The brand frequency chart demonstrates broad manufacturer representation. Although brands such as Specialized and Shimano appear more frequently, no single manufacturer dominates the dataset, reducing the likelihood of brand-specific bias during modeling.</a:t>
+              <a:t>The manufacturer frequency chart demonstrates broad manufacturer representation. Although brands such as Specialized and Shimano appear more frequently, no single manufacturer dominates the dataset, reducing the likelihood of brand-specific bias during modeling.</a:t>
             </a:r>
           </a:p>
           <a:p>
@@ -7006,6 +6986,12 @@
           <a:p>
             <a:r>
               <a:rPr lang="en-US" dirty="0"/>
+              <a:t>It's important to note that these engineered variables are not intended to replace the review text. Instead, they provide structured context that complements the raw text, while the transformer model will learn the semantic meaning directly from the article title and review content.</a:t>
+            </a:r>
+          </a:p>
+          <a:p>
+            <a:r>
+              <a:rPr lang="en-US" dirty="0"/>
               <a:t>I also created a product name availability indicator during exploratory analysis. Although this feature is not intended as a predictive input, it serves as a useful measure of metadata completeness and highlights an opportunity to further improve the ETL pipeline before the final stages of the project.</a:t>
             </a:r>
           </a:p>
@@ -7197,19 +7183,42 @@
           <a:lstStyle/>
           <a:p>
             <a:r>
-              <a:rPr lang="en-US" dirty="0"/>
+              <a:rPr lang="en-US" b="0" dirty="0"/>
               <a:t>The purpose of exploratory analysis and feature engineering is not simply to prepare data for modeling, but also to ensure that the resulting models produce insights that are meaningful to business users. While transformer models will classify sentiment from the review text, the structured metadata provides the context needed to interpret those predictions.</a:t>
             </a:r>
           </a:p>
           <a:p>
             <a:r>
-              <a:rPr lang="en-US" dirty="0"/>
-              <a:t>Features such as brand, review type, retail price, and publication date allow organizations to compare sentiment across manufacturers, product segments, and time periods. Rather than simply determining whether a review is positive or negative, these features help explain where sentiment differs and identify patterns that can inform product development, competitive analysis, and marketing strategy.</a:t>
+              <a:rPr lang="en-US" b="0" dirty="0"/>
+              <a:t>Features such as brand, review type, retail price, and publication date allow organizations to compare sentiment across manufacturers, product segments, and time periods. Rather than simply predicting sentiment, these features help explain why sentiment differs across manufacturers, product segments, price ranges, and time periods.</a:t>
             </a:r>
           </a:p>
           <a:p>
+            <a:pPr marL="0" marR="0" lvl="0" indent="0" algn="l" defTabSz="914400" rtl="0" eaLnBrk="1" fontAlgn="auto" latinLnBrk="0" hangingPunct="1">
+              <a:lnSpc>
+                <a:spcPct val="100000"/>
+              </a:lnSpc>
+              <a:spcBef>
+                <a:spcPts val="0"/>
+              </a:spcBef>
+              <a:spcAft>
+                <a:spcPts val="0"/>
+              </a:spcAft>
+              <a:buClrTx/>
+              <a:buSzTx/>
+              <a:buFontTx/>
+              <a:buNone/>
+              <a:tabLst/>
+              <a:defRPr/>
+            </a:pPr>
             <a:r>
-              <a:rPr lang="en-US" dirty="0"/>
+              <a:rPr lang="en-US" b="0" dirty="0"/>
+              <a:t>These structured features also allow sentiment results to be segmented by manufacturer, review type, publication date, and price range, making the model outputs more actionable for business decision-making.</a:t>
+            </a:r>
+          </a:p>
+          <a:p>
+            <a:r>
+              <a:rPr lang="en-US" b="0" dirty="0"/>
               <a:t>By combining structured metadata with transformer-based text analysis, this project aims to deliver interpretable business insights that extend beyond basic sentiment classification.</a:t>
             </a:r>
           </a:p>
@@ -7301,24 +7310,27 @@
             </a:r>
           </a:p>
           <a:p>
+            <a:pPr marL="0" marR="0" lvl="0" indent="0" algn="l" defTabSz="914400" rtl="0" eaLnBrk="1" fontAlgn="auto" latinLnBrk="0" hangingPunct="1">
+              <a:lnSpc>
+                <a:spcPct val="100000"/>
+              </a:lnSpc>
+              <a:spcBef>
+                <a:spcPts val="0"/>
+              </a:spcBef>
+              <a:spcAft>
+                <a:spcPts val="0"/>
+              </a:spcAft>
+              <a:buClrTx/>
+              <a:buSzTx/>
+              <a:buFontTx/>
+              <a:buNone/>
+              <a:tabLst/>
+              <a:defRPr/>
+            </a:pPr>
             <a:r>
               <a:rPr lang="en-US" dirty="0"/>
-              <a:t>Although exploratory analysis also identified opportunities to further improve product metadata extraction, these findings do not impact the availability or quality of the review text that will be used for sentiment modeling.</a:t>
+              <a:t>Although exploratory analysis identified a small number of remaining metadata limitations, the review text itself is complete across all records, providing a strong foundation for transformer-based sentiment modeling. The next phase of the project will focus on generating review-level sentiment labels, training and comparing transformer-based NLP models, and evaluating both predictive performance and the business insights that can be derived from the resulting classifications.</a:t>
             </a:r>
-          </a:p>
-          <a:p>
-            <a:r>
-              <a:rPr lang="en-US" dirty="0"/>
-              <a:t>The next phase of the project will focus on generating sentiment labels, training and comparing transformer-based NLP models, and evaluating both predictive performance and the business insights that can be derived from the resulting </a:t>
-            </a:r>
-            <a:r>
-              <a:rPr lang="en-US"/>
-              <a:t>classifications.</a:t>
-            </a:r>
-            <a:endParaRPr lang="en-US" dirty="0"/>
-          </a:p>
-          <a:p>
-            <a:endParaRPr lang="en-US" dirty="0"/>
           </a:p>
         </p:txBody>
       </p:sp>
@@ -7546,7 +7558,7 @@
           <a:p>
             <a:fld id="{755DF60E-8B57-924B-825F-23BE3BB50F9C}" type="datetimeFigureOut">
               <a:rPr lang="en-US" smtClean="0"/>
-              <a:t>7/5/26</a:t>
+              <a:t>7/9/26</a:t>
             </a:fld>
             <a:endParaRPr lang="en-US"/>
           </a:p>
@@ -7891,7 +7903,7 @@
           <a:p>
             <a:fld id="{755DF60E-8B57-924B-825F-23BE3BB50F9C}" type="datetimeFigureOut">
               <a:rPr lang="en-US" smtClean="0"/>
-              <a:t>7/5/26</a:t>
+              <a:t>7/9/26</a:t>
             </a:fld>
             <a:endParaRPr lang="en-US"/>
           </a:p>
@@ -8292,7 +8304,7 @@
           <a:p>
             <a:fld id="{755DF60E-8B57-924B-825F-23BE3BB50F9C}" type="datetimeFigureOut">
               <a:rPr lang="en-US" smtClean="0"/>
-              <a:t>7/5/26</a:t>
+              <a:t>7/9/26</a:t>
             </a:fld>
             <a:endParaRPr lang="en-US"/>
           </a:p>
@@ -8628,7 +8640,7 @@
           <a:p>
             <a:fld id="{755DF60E-8B57-924B-825F-23BE3BB50F9C}" type="datetimeFigureOut">
               <a:rPr lang="en-US" smtClean="0"/>
-              <a:t>7/5/26</a:t>
+              <a:t>7/9/26</a:t>
             </a:fld>
             <a:endParaRPr lang="en-US"/>
           </a:p>
@@ -8948,7 +8960,7 @@
           <a:p>
             <a:fld id="{755DF60E-8B57-924B-825F-23BE3BB50F9C}" type="datetimeFigureOut">
               <a:rPr lang="en-US" smtClean="0"/>
-              <a:t>7/5/26</a:t>
+              <a:t>7/9/26</a:t>
             </a:fld>
             <a:endParaRPr lang="en-US"/>
           </a:p>
@@ -9344,7 +9356,7 @@
           <a:p>
             <a:fld id="{755DF60E-8B57-924B-825F-23BE3BB50F9C}" type="datetimeFigureOut">
               <a:rPr lang="en-US" smtClean="0"/>
-              <a:t>7/5/26</a:t>
+              <a:t>7/9/26</a:t>
             </a:fld>
             <a:endParaRPr lang="en-US"/>
           </a:p>
@@ -9601,7 +9613,7 @@
           <a:p>
             <a:fld id="{755DF60E-8B57-924B-825F-23BE3BB50F9C}" type="datetimeFigureOut">
               <a:rPr lang="en-US" smtClean="0"/>
-              <a:t>7/5/26</a:t>
+              <a:t>7/9/26</a:t>
             </a:fld>
             <a:endParaRPr lang="en-US"/>
           </a:p>
@@ -9863,7 +9875,7 @@
           <a:p>
             <a:fld id="{755DF60E-8B57-924B-825F-23BE3BB50F9C}" type="datetimeFigureOut">
               <a:rPr lang="en-US" smtClean="0"/>
-              <a:t>7/5/26</a:t>
+              <a:t>7/9/26</a:t>
             </a:fld>
             <a:endParaRPr lang="en-US"/>
           </a:p>
@@ -10125,7 +10137,7 @@
           <a:p>
             <a:fld id="{755DF60E-8B57-924B-825F-23BE3BB50F9C}" type="datetimeFigureOut">
               <a:rPr lang="en-US" smtClean="0"/>
-              <a:t>7/5/26</a:t>
+              <a:t>7/9/26</a:t>
             </a:fld>
             <a:endParaRPr lang="en-US"/>
           </a:p>
@@ -10454,7 +10466,7 @@
           <a:p>
             <a:fld id="{755DF60E-8B57-924B-825F-23BE3BB50F9C}" type="datetimeFigureOut">
               <a:rPr lang="en-US" smtClean="0"/>
-              <a:t>7/5/26</a:t>
+              <a:t>7/9/26</a:t>
             </a:fld>
             <a:endParaRPr lang="en-US"/>
           </a:p>
@@ -10777,7 +10789,7 @@
           <a:p>
             <a:fld id="{755DF60E-8B57-924B-825F-23BE3BB50F9C}" type="datetimeFigureOut">
               <a:rPr lang="en-US" smtClean="0"/>
-              <a:t>7/5/26</a:t>
+              <a:t>7/9/26</a:t>
             </a:fld>
             <a:endParaRPr lang="en-US"/>
           </a:p>
@@ -11241,7 +11253,7 @@
           <a:p>
             <a:fld id="{755DF60E-8B57-924B-825F-23BE3BB50F9C}" type="datetimeFigureOut">
               <a:rPr lang="en-US" smtClean="0"/>
-              <a:t>7/5/26</a:t>
+              <a:t>7/9/26</a:t>
             </a:fld>
             <a:endParaRPr lang="en-US"/>
           </a:p>
@@ -11446,7 +11458,7 @@
           <a:p>
             <a:fld id="{755DF60E-8B57-924B-825F-23BE3BB50F9C}" type="datetimeFigureOut">
               <a:rPr lang="en-US" smtClean="0"/>
-              <a:t>7/5/26</a:t>
+              <a:t>7/9/26</a:t>
             </a:fld>
             <a:endParaRPr lang="en-US"/>
           </a:p>
@@ -11623,7 +11635,7 @@
           <a:p>
             <a:fld id="{755DF60E-8B57-924B-825F-23BE3BB50F9C}" type="datetimeFigureOut">
               <a:rPr lang="en-US" smtClean="0"/>
-              <a:t>7/5/26</a:t>
+              <a:t>7/9/26</a:t>
             </a:fld>
             <a:endParaRPr lang="en-US"/>
           </a:p>
@@ -11956,7 +11968,7 @@
           <a:p>
             <a:fld id="{755DF60E-8B57-924B-825F-23BE3BB50F9C}" type="datetimeFigureOut">
               <a:rPr lang="en-US" smtClean="0"/>
-              <a:t>7/5/26</a:t>
+              <a:t>7/9/26</a:t>
             </a:fld>
             <a:endParaRPr lang="en-US"/>
           </a:p>
@@ -12301,7 +12313,7 @@
           <a:p>
             <a:fld id="{755DF60E-8B57-924B-825F-23BE3BB50F9C}" type="datetimeFigureOut">
               <a:rPr lang="en-US" smtClean="0"/>
-              <a:t>7/5/26</a:t>
+              <a:t>7/9/26</a:t>
             </a:fld>
             <a:endParaRPr lang="en-US"/>
           </a:p>
@@ -14593,7 +14605,7 @@
           <a:p>
             <a:fld id="{755DF60E-8B57-924B-825F-23BE3BB50F9C}" type="datetimeFigureOut">
               <a:rPr lang="en-US" smtClean="0"/>
-              <a:t>7/5/26</a:t>
+              <a:t>7/9/26</a:t>
             </a:fld>
             <a:endParaRPr lang="en-US"/>
           </a:p>
@@ -15274,7 +15286,7 @@
             <p:ph sz="half" idx="1"/>
             <p:extLst>
               <p:ext uri="{D42A27DB-BD31-4B8C-83A1-F6EECF244321}">
-                <p14:modId xmlns:p14="http://schemas.microsoft.com/office/powerpoint/2010/main" val="2474894591"/>
+                <p14:modId xmlns:p14="http://schemas.microsoft.com/office/powerpoint/2010/main" val="2166414921"/>
               </p:ext>
             </p:extLst>
           </p:nvPr>
@@ -15359,7 +15371,7 @@
                     <a:p>
                       <a:r>
                         <a:rPr lang="en-US" dirty="0"/>
-                        <a:t>296</a:t>
+                        <a:t>297</a:t>
                       </a:r>
                     </a:p>
                   </a:txBody>
@@ -15379,7 +15391,7 @@
                     <a:p>
                       <a:r>
                         <a:rPr lang="en-US" dirty="0"/>
-                        <a:t>Variables</a:t>
+                        <a:t>Features</a:t>
                       </a:r>
                     </a:p>
                   </a:txBody>
@@ -15392,7 +15404,7 @@
                     <a:p>
                       <a:r>
                         <a:rPr lang="en-US" dirty="0"/>
-                        <a:t>25</a:t>
+                        <a:t>17</a:t>
                       </a:r>
                     </a:p>
                   </a:txBody>
@@ -15425,7 +15437,7 @@
                     <a:p>
                       <a:r>
                         <a:rPr lang="en-US" dirty="0"/>
-                        <a:t>127</a:t>
+                        <a:t>151</a:t>
                       </a:r>
                     </a:p>
                   </a:txBody>
@@ -15524,7 +15536,7 @@
                     <a:p>
                       <a:r>
                         <a:rPr lang="en-US" dirty="0"/>
-                        <a:t>2,238 words</a:t>
+                        <a:t>2,241 words</a:t>
                       </a:r>
                     </a:p>
                   </a:txBody>
@@ -15645,7 +15657,7 @@
             <p:ph sz="half" idx="1"/>
             <p:extLst>
               <p:ext uri="{D42A27DB-BD31-4B8C-83A1-F6EECF244321}">
-                <p14:modId xmlns:p14="http://schemas.microsoft.com/office/powerpoint/2010/main" val="3023395651"/>
+                <p14:modId xmlns:p14="http://schemas.microsoft.com/office/powerpoint/2010/main" val="1522486013"/>
               </p:ext>
             </p:extLst>
           </p:nvPr>
@@ -15750,7 +15762,7 @@
                     <a:p>
                       <a:r>
                         <a:rPr lang="en-US" dirty="0"/>
-                        <a:t>$3,423</a:t>
+                        <a:t>$3,429</a:t>
                       </a:r>
                     </a:p>
                   </a:txBody>
@@ -15763,7 +15775,7 @@
                     <a:p>
                       <a:r>
                         <a:rPr lang="en-US" dirty="0"/>
-                        <a:t>2,238</a:t>
+                        <a:t>2,241</a:t>
                       </a:r>
                     </a:p>
                   </a:txBody>
@@ -15809,7 +15821,7 @@
                     <a:p>
                       <a:r>
                         <a:rPr lang="en-US" dirty="0"/>
-                        <a:t>1,967</a:t>
+                        <a:t>1,972</a:t>
                       </a:r>
                     </a:p>
                   </a:txBody>
@@ -15855,7 +15867,7 @@
                     <a:p>
                       <a:r>
                         <a:rPr lang="en-US" dirty="0"/>
-                        <a:t>0.49</a:t>
+                        <a:t>0.48</a:t>
                       </a:r>
                     </a:p>
                   </a:txBody>
@@ -15890,7 +15902,7 @@
         <p:spPr/>
         <p:txBody>
           <a:bodyPr>
-            <a:normAutofit lnSpcReduction="10000"/>
+            <a:normAutofit fontScale="92500" lnSpcReduction="10000"/>
           </a:bodyPr>
           <a:lstStyle/>
           <a:p>
@@ -15914,7 +15926,7 @@
           <a:p>
             <a:r>
               <a:rPr lang="en-US" dirty="0"/>
-              <a:t>Missing values primarily limited to </a:t>
+              <a:t>Missing values are primarily limited to </a:t>
             </a:r>
             <a:r>
               <a:rPr lang="en-US" dirty="0" err="1"/>
@@ -15922,7 +15934,7 @@
             </a:r>
             <a:r>
               <a:rPr lang="en-US" dirty="0"/>
-              <a:t>, representing an opportunity for future ETL improvements</a:t>
+              <a:t> for multi-product and editorial articles, with a small number remaining due to metadata extraction limitations.</a:t>
             </a:r>
           </a:p>
         </p:txBody>
@@ -15986,130 +15998,6 @@
           </a:p>
         </p:txBody>
       </p:sp>
-      <p:pic>
-        <p:nvPicPr>
-          <p:cNvPr id="6" name="Content Placeholder 5">
-            <a:extLst>
-              <a:ext uri="{FF2B5EF4-FFF2-40B4-BE49-F238E27FC236}">
-                <a16:creationId xmlns:a16="http://schemas.microsoft.com/office/drawing/2014/main" id="{9AD6AFDF-EC02-935F-F946-930B1FA82D20}"/>
-              </a:ext>
-            </a:extLst>
-          </p:cNvPr>
-          <p:cNvPicPr>
-            <a:picLocks noGrp="1" noChangeAspect="1"/>
-          </p:cNvPicPr>
-          <p:nvPr>
-            <p:ph sz="half" idx="1"/>
-          </p:nvPr>
-        </p:nvPicPr>
-        <p:blipFill>
-          <a:blip r:embed="rId3"/>
-          <a:stretch>
-            <a:fillRect/>
-          </a:stretch>
-        </p:blipFill>
-        <p:spPr>
-          <a:xfrm>
-            <a:off x="1235078" y="1264555"/>
-            <a:ext cx="4313237" cy="2164445"/>
-          </a:xfrm>
-          <a:prstGeom prst="rect">
-            <a:avLst/>
-          </a:prstGeom>
-        </p:spPr>
-      </p:pic>
-      <p:pic>
-        <p:nvPicPr>
-          <p:cNvPr id="8" name="Content Placeholder 7">
-            <a:extLst>
-              <a:ext uri="{FF2B5EF4-FFF2-40B4-BE49-F238E27FC236}">
-                <a16:creationId xmlns:a16="http://schemas.microsoft.com/office/drawing/2014/main" id="{0B699FF0-3A75-00A2-00BD-EEAE17B91966}"/>
-              </a:ext>
-            </a:extLst>
-          </p:cNvPr>
-          <p:cNvPicPr>
-            <a:picLocks noGrp="1" noChangeAspect="1"/>
-          </p:cNvPicPr>
-          <p:nvPr>
-            <p:ph sz="half" idx="2"/>
-          </p:nvPr>
-        </p:nvPicPr>
-        <p:blipFill>
-          <a:blip r:embed="rId4"/>
-          <a:stretch>
-            <a:fillRect/>
-          </a:stretch>
-        </p:blipFill>
-        <p:spPr>
-          <a:xfrm>
-            <a:off x="6643684" y="1264555"/>
-            <a:ext cx="4313238" cy="2164445"/>
-          </a:xfrm>
-          <a:prstGeom prst="rect">
-            <a:avLst/>
-          </a:prstGeom>
-        </p:spPr>
-      </p:pic>
-      <p:pic>
-        <p:nvPicPr>
-          <p:cNvPr id="10" name="Picture 9">
-            <a:extLst>
-              <a:ext uri="{FF2B5EF4-FFF2-40B4-BE49-F238E27FC236}">
-                <a16:creationId xmlns:a16="http://schemas.microsoft.com/office/drawing/2014/main" id="{B9152051-52B0-2117-B752-D3738CF35031}"/>
-              </a:ext>
-            </a:extLst>
-          </p:cNvPr>
-          <p:cNvPicPr>
-            <a:picLocks noChangeAspect="1"/>
-          </p:cNvPicPr>
-          <p:nvPr/>
-        </p:nvPicPr>
-        <p:blipFill>
-          <a:blip r:embed="rId5"/>
-          <a:stretch>
-            <a:fillRect/>
-          </a:stretch>
-        </p:blipFill>
-        <p:spPr>
-          <a:xfrm>
-            <a:off x="1235078" y="3672296"/>
-            <a:ext cx="4313237" cy="2164445"/>
-          </a:xfrm>
-          <a:prstGeom prst="rect">
-            <a:avLst/>
-          </a:prstGeom>
-        </p:spPr>
-      </p:pic>
-      <p:pic>
-        <p:nvPicPr>
-          <p:cNvPr id="12" name="Picture 11">
-            <a:extLst>
-              <a:ext uri="{FF2B5EF4-FFF2-40B4-BE49-F238E27FC236}">
-                <a16:creationId xmlns:a16="http://schemas.microsoft.com/office/drawing/2014/main" id="{F4C92F27-266B-5EC8-4F3E-29B5A5165218}"/>
-              </a:ext>
-            </a:extLst>
-          </p:cNvPr>
-          <p:cNvPicPr>
-            <a:picLocks noChangeAspect="1"/>
-          </p:cNvPicPr>
-          <p:nvPr/>
-        </p:nvPicPr>
-        <p:blipFill>
-          <a:blip r:embed="rId6"/>
-          <a:stretch>
-            <a:fillRect/>
-          </a:stretch>
-        </p:blipFill>
-        <p:spPr>
-          <a:xfrm>
-            <a:off x="6665640" y="3659122"/>
-            <a:ext cx="4291282" cy="2177620"/>
-          </a:xfrm>
-          <a:prstGeom prst="rect">
-            <a:avLst/>
-          </a:prstGeom>
-        </p:spPr>
-      </p:pic>
       <p:sp>
         <p:nvSpPr>
           <p:cNvPr id="13" name="TextBox 12">
@@ -16139,12 +16027,133 @@
           <a:lstStyle/>
           <a:p>
             <a:r>
-              <a:rPr lang="en-US" sz="1400" dirty="0"/>
-              <a:t>Visual exploration confirmed consistent review lengths, broad brand representation, and structured review types, supporting downstream NLP feature engineering and model development.</a:t>
+              <a:rPr lang="en-US" sz="1400"/>
+              <a:t>Visual exploration confirmed consistent review lengths, broad brand representation, and structured review types, supporting feature engineering, text preprocessing, and downstream NLP model development.</a:t>
             </a:r>
+            <a:endParaRPr lang="en-US" sz="1400" dirty="0"/>
           </a:p>
         </p:txBody>
       </p:sp>
+      <p:pic>
+        <p:nvPicPr>
+          <p:cNvPr id="21" name="Picture 20">
+            <a:extLst>
+              <a:ext uri="{FF2B5EF4-FFF2-40B4-BE49-F238E27FC236}">
+                <a16:creationId xmlns:a16="http://schemas.microsoft.com/office/drawing/2014/main" id="{5687FB81-4C1F-BD5A-FD59-850AF07E3FBC}"/>
+              </a:ext>
+            </a:extLst>
+          </p:cNvPr>
+          <p:cNvPicPr>
+            <a:picLocks noChangeAspect="1"/>
+          </p:cNvPicPr>
+          <p:nvPr/>
+        </p:nvPicPr>
+        <p:blipFill>
+          <a:blip r:embed="rId3"/>
+          <a:stretch>
+            <a:fillRect/>
+          </a:stretch>
+        </p:blipFill>
+        <p:spPr>
+          <a:xfrm>
+            <a:off x="1235078" y="1264555"/>
+            <a:ext cx="4987013" cy="2286000"/>
+          </a:xfrm>
+          <a:prstGeom prst="rect">
+            <a:avLst/>
+          </a:prstGeom>
+        </p:spPr>
+      </p:pic>
+      <p:pic>
+        <p:nvPicPr>
+          <p:cNvPr id="23" name="Picture 22">
+            <a:extLst>
+              <a:ext uri="{FF2B5EF4-FFF2-40B4-BE49-F238E27FC236}">
+                <a16:creationId xmlns:a16="http://schemas.microsoft.com/office/drawing/2014/main" id="{9A8E5BF5-E5D5-72E7-0630-393998BEE99E}"/>
+              </a:ext>
+            </a:extLst>
+          </p:cNvPr>
+          <p:cNvPicPr>
+            <a:picLocks noChangeAspect="1"/>
+          </p:cNvPicPr>
+          <p:nvPr/>
+        </p:nvPicPr>
+        <p:blipFill>
+          <a:blip r:embed="rId4"/>
+          <a:stretch>
+            <a:fillRect/>
+          </a:stretch>
+        </p:blipFill>
+        <p:spPr>
+          <a:xfrm>
+            <a:off x="1235078" y="3550555"/>
+            <a:ext cx="4983480" cy="2286000"/>
+          </a:xfrm>
+          <a:prstGeom prst="rect">
+            <a:avLst/>
+          </a:prstGeom>
+        </p:spPr>
+      </p:pic>
+      <p:pic>
+        <p:nvPicPr>
+          <p:cNvPr id="51" name="Picture 50">
+            <a:extLst>
+              <a:ext uri="{FF2B5EF4-FFF2-40B4-BE49-F238E27FC236}">
+                <a16:creationId xmlns:a16="http://schemas.microsoft.com/office/drawing/2014/main" id="{786473AF-4F5D-59C2-6788-0BF942932669}"/>
+              </a:ext>
+            </a:extLst>
+          </p:cNvPr>
+          <p:cNvPicPr>
+            <a:picLocks noChangeAspect="1"/>
+          </p:cNvPicPr>
+          <p:nvPr/>
+        </p:nvPicPr>
+        <p:blipFill>
+          <a:blip r:embed="rId5"/>
+          <a:stretch>
+            <a:fillRect/>
+          </a:stretch>
+        </p:blipFill>
+        <p:spPr>
+          <a:xfrm>
+            <a:off x="6218558" y="1264555"/>
+            <a:ext cx="4983480" cy="2286000"/>
+          </a:xfrm>
+          <a:prstGeom prst="rect">
+            <a:avLst/>
+          </a:prstGeom>
+        </p:spPr>
+      </p:pic>
+      <p:pic>
+        <p:nvPicPr>
+          <p:cNvPr id="55" name="Picture 54">
+            <a:extLst>
+              <a:ext uri="{FF2B5EF4-FFF2-40B4-BE49-F238E27FC236}">
+                <a16:creationId xmlns:a16="http://schemas.microsoft.com/office/drawing/2014/main" id="{B079D735-2205-09E8-852B-264A16305D89}"/>
+              </a:ext>
+            </a:extLst>
+          </p:cNvPr>
+          <p:cNvPicPr>
+            <a:picLocks noChangeAspect="1"/>
+          </p:cNvPicPr>
+          <p:nvPr/>
+        </p:nvPicPr>
+        <p:blipFill>
+          <a:blip r:embed="rId6"/>
+          <a:stretch>
+            <a:fillRect/>
+          </a:stretch>
+        </p:blipFill>
+        <p:spPr>
+          <a:xfrm>
+            <a:off x="6222090" y="3550553"/>
+            <a:ext cx="4979947" cy="2286001"/>
+          </a:xfrm>
+          <a:prstGeom prst="rect">
+            <a:avLst/>
+          </a:prstGeom>
+        </p:spPr>
+      </p:pic>
     </p:spTree>
     <p:extLst>
       <p:ext uri="{BB962C8B-B14F-4D97-AF65-F5344CB8AC3E}">
@@ -16222,7 +16231,7 @@
         <p:spPr>
           <a:xfrm>
             <a:off x="1360245" y="1509085"/>
-            <a:ext cx="2506571" cy="3777622"/>
+            <a:ext cx="3148693" cy="3777622"/>
           </a:xfrm>
         </p:spPr>
         <p:txBody>
@@ -16234,7 +16243,7 @@
             </a:pPr>
             <a:r>
               <a:rPr lang="en-US" sz="2000" u="sng" dirty="0"/>
-              <a:t>Original Features</a:t>
+              <a:t>Primary Modeling Inputs</a:t>
             </a:r>
           </a:p>
           <a:p>
@@ -16291,14 +16300,14 @@
             <p:ph sz="half" idx="2"/>
             <p:extLst>
               <p:ext uri="{D42A27DB-BD31-4B8C-83A1-F6EECF244321}">
-                <p14:modId xmlns:p14="http://schemas.microsoft.com/office/powerpoint/2010/main" val="4241430616"/>
+                <p14:modId xmlns:p14="http://schemas.microsoft.com/office/powerpoint/2010/main" val="3395417758"/>
               </p:ext>
             </p:extLst>
           </p:nvPr>
         </p:nvGraphicFramePr>
         <p:xfrm>
-          <a:off x="3866816" y="1509085"/>
-          <a:ext cx="7637795" cy="3942080"/>
+          <a:off x="4508938" y="1509085"/>
+          <a:ext cx="7051643" cy="4216400"/>
         </p:xfrm>
         <a:graphic>
           <a:graphicData uri="http://schemas.openxmlformats.org/drawingml/2006/table">
@@ -16307,7 +16316,7 @@
                 <a:tableStyleId>{5C22544A-7EE6-4342-B048-85BDC9FD1C3A}</a:tableStyleId>
               </a:tblPr>
               <a:tblGrid>
-                <a:gridCol w="3218545">
+                <a:gridCol w="2632393">
                   <a:extLst>
                     <a:ext uri="{9D8B030D-6E8A-4147-A177-3AD203B41FA5}">
                       <a16:colId xmlns:a16="http://schemas.microsoft.com/office/drawing/2014/main" val="2501205287"/>
@@ -16396,7 +16405,7 @@
                     <a:p>
                       <a:r>
                         <a:rPr lang="en-US" dirty="0"/>
-                        <a:t>Average Word Count</a:t>
+                        <a:t>Average Word Length</a:t>
                       </a:r>
                     </a:p>
                   </a:txBody>
@@ -16541,7 +16550,7 @@
                     <a:p>
                       <a:r>
                         <a:rPr lang="en-US" dirty="0"/>
-                        <a:t>Track metadata completeness and future ETL improvements</a:t>
+                        <a:t>Evaluate metadata completeness and support future ETL quality improvements</a:t>
                       </a:r>
                     </a:p>
                   </a:txBody>
@@ -17296,7 +17305,7 @@
           <a:p>
             <a:r>
               <a:rPr lang="en-US" dirty="0"/>
-              <a:t>Transformer embeddings provides an effective text representation without requiring PCA</a:t>
+              <a:t>Transformer embeddings provide an effective text representation without requiring PCA</a:t>
             </a:r>
           </a:p>
         </p:txBody>
@@ -17341,15 +17350,7 @@
           <a:p>
             <a:r>
               <a:rPr lang="en-US" dirty="0"/>
-              <a:t>Improve </a:t>
-            </a:r>
-            <a:r>
-              <a:rPr lang="en-US" dirty="0" err="1"/>
-              <a:t>product_name</a:t>
-            </a:r>
-            <a:r>
-              <a:rPr lang="en-US" dirty="0"/>
-              <a:t> extraction during ETL</a:t>
+              <a:t>Finalize the NLP training dataset</a:t>
             </a:r>
           </a:p>
           <a:p>

</xml_diff>